<commit_message>
Updated Model_book 5 and PPT.
</commit_message>
<xml_diff>
--- a/docs/Clg 1st review.pptx
+++ b/docs/Clg 1st review.pptx
@@ -121,6 +121,11 @@
       </a:defRPr>
     </a:lvl9pPr>
   </p:defaultTextStyle>
+  <p:extLst>
+    <p:ext uri="{EFAFB233-063F-42B5-8137-9DF3F51BA10A}">
+      <p15:sldGuideLst xmlns:p15="http://schemas.microsoft.com/office/powerpoint/2012/main"/>
+    </p:ext>
+  </p:extLst>
 </p:presentation>
 </file>
 
@@ -206,7 +211,7 @@
           <a:p>
             <a:fld id="{C1BED7E8-5420-4F73-BA32-34A7030FE7D8}" type="datetimeFigureOut">
               <a:rPr lang="en-US" smtClean="0"/>
-              <a:t>2/15/2026</a:t>
+              <a:t>2/16/2026</a:t>
             </a:fld>
             <a:endParaRPr lang="en-US"/>
           </a:p>
@@ -1868,7 +1873,7 @@
           <a:p>
             <a:fld id="{C198EE3F-C531-4F47-81BE-EB7857D8F039}" type="datetimeFigureOut">
               <a:rPr lang="en-US" smtClean="0"/>
-              <a:t>2/15/2026</a:t>
+              <a:t>2/16/2026</a:t>
             </a:fld>
             <a:endParaRPr lang="en-US"/>
           </a:p>
@@ -2066,7 +2071,7 @@
           <a:p>
             <a:fld id="{C198EE3F-C531-4F47-81BE-EB7857D8F039}" type="datetimeFigureOut">
               <a:rPr lang="en-US" smtClean="0"/>
-              <a:t>2/15/2026</a:t>
+              <a:t>2/16/2026</a:t>
             </a:fld>
             <a:endParaRPr lang="en-US"/>
           </a:p>
@@ -2274,7 +2279,7 @@
           <a:p>
             <a:fld id="{C198EE3F-C531-4F47-81BE-EB7857D8F039}" type="datetimeFigureOut">
               <a:rPr lang="en-US" smtClean="0"/>
-              <a:t>2/15/2026</a:t>
+              <a:t>2/16/2026</a:t>
             </a:fld>
             <a:endParaRPr lang="en-US"/>
           </a:p>
@@ -2472,7 +2477,7 @@
           <a:p>
             <a:fld id="{C198EE3F-C531-4F47-81BE-EB7857D8F039}" type="datetimeFigureOut">
               <a:rPr lang="en-US" smtClean="0"/>
-              <a:t>2/15/2026</a:t>
+              <a:t>2/16/2026</a:t>
             </a:fld>
             <a:endParaRPr lang="en-US"/>
           </a:p>
@@ -2747,7 +2752,7 @@
           <a:p>
             <a:fld id="{C198EE3F-C531-4F47-81BE-EB7857D8F039}" type="datetimeFigureOut">
               <a:rPr lang="en-US" smtClean="0"/>
-              <a:t>2/15/2026</a:t>
+              <a:t>2/16/2026</a:t>
             </a:fld>
             <a:endParaRPr lang="en-US"/>
           </a:p>
@@ -3012,7 +3017,7 @@
           <a:p>
             <a:fld id="{C198EE3F-C531-4F47-81BE-EB7857D8F039}" type="datetimeFigureOut">
               <a:rPr lang="en-US" smtClean="0"/>
-              <a:t>2/15/2026</a:t>
+              <a:t>2/16/2026</a:t>
             </a:fld>
             <a:endParaRPr lang="en-US"/>
           </a:p>
@@ -3424,7 +3429,7 @@
           <a:p>
             <a:fld id="{C198EE3F-C531-4F47-81BE-EB7857D8F039}" type="datetimeFigureOut">
               <a:rPr lang="en-US" smtClean="0"/>
-              <a:t>2/15/2026</a:t>
+              <a:t>2/16/2026</a:t>
             </a:fld>
             <a:endParaRPr lang="en-US"/>
           </a:p>
@@ -3565,7 +3570,7 @@
           <a:p>
             <a:fld id="{C198EE3F-C531-4F47-81BE-EB7857D8F039}" type="datetimeFigureOut">
               <a:rPr lang="en-US" smtClean="0"/>
-              <a:t>2/15/2026</a:t>
+              <a:t>2/16/2026</a:t>
             </a:fld>
             <a:endParaRPr lang="en-US"/>
           </a:p>
@@ -3678,7 +3683,7 @@
           <a:p>
             <a:fld id="{C198EE3F-C531-4F47-81BE-EB7857D8F039}" type="datetimeFigureOut">
               <a:rPr lang="en-US" smtClean="0"/>
-              <a:t>2/15/2026</a:t>
+              <a:t>2/16/2026</a:t>
             </a:fld>
             <a:endParaRPr lang="en-US"/>
           </a:p>
@@ -3989,7 +3994,7 @@
           <a:p>
             <a:fld id="{C198EE3F-C531-4F47-81BE-EB7857D8F039}" type="datetimeFigureOut">
               <a:rPr lang="en-US" smtClean="0"/>
-              <a:t>2/15/2026</a:t>
+              <a:t>2/16/2026</a:t>
             </a:fld>
             <a:endParaRPr lang="en-US"/>
           </a:p>
@@ -4277,7 +4282,7 @@
           <a:p>
             <a:fld id="{C198EE3F-C531-4F47-81BE-EB7857D8F039}" type="datetimeFigureOut">
               <a:rPr lang="en-US" smtClean="0"/>
-              <a:t>2/15/2026</a:t>
+              <a:t>2/16/2026</a:t>
             </a:fld>
             <a:endParaRPr lang="en-US"/>
           </a:p>
@@ -4518,7 +4523,7 @@
           <a:p>
             <a:fld id="{C198EE3F-C531-4F47-81BE-EB7857D8F039}" type="datetimeFigureOut">
               <a:rPr lang="en-US" smtClean="0"/>
-              <a:t>2/15/2026</a:t>
+              <a:t>2/16/2026</a:t>
             </a:fld>
             <a:endParaRPr lang="en-US"/>
           </a:p>
@@ -7310,7 +7315,7 @@
         <p:spPr>
           <a:xfrm>
             <a:off x="265471" y="792624"/>
-            <a:ext cx="11661058" cy="5016758"/>
+            <a:ext cx="11661058" cy="4401205"/>
           </a:xfrm>
           <a:prstGeom prst="rect">
             <a:avLst/>
@@ -7411,19 +7416,6 @@
                 <a:cs typeface="Times New Roman" panose="02020603050405020304" pitchFamily="18" charset="0"/>
               </a:rPr>
               <a:t>Supports cloud deployment for scalability, enabling the system to handle increasing volumes of data and multiple equipment units efficiently.</a:t>
-            </a:r>
-          </a:p>
-          <a:p>
-            <a:pPr marL="342900" indent="-342900">
-              <a:buFont typeface="Wingdings" panose="05000000000000000000" pitchFamily="2" charset="2"/>
-              <a:buChar char="ü"/>
-            </a:pPr>
-            <a:r>
-              <a:rPr lang="en-US" sz="2000" dirty="0">
-                <a:latin typeface="Times New Roman" panose="02020603050405020304" pitchFamily="18" charset="0"/>
-                <a:cs typeface="Times New Roman" panose="02020603050405020304" pitchFamily="18" charset="0"/>
-              </a:rPr>
-              <a:t>Enables real-time monitoring from anywhere, improving accessibility and faster decision-making for maintenance teams.</a:t>
             </a:r>
           </a:p>
           <a:p>

</xml_diff>

<commit_message>
Edit Logo in PPT
</commit_message>
<xml_diff>
--- a/docs/Clg 1st review.pptx
+++ b/docs/Clg 1st review.pptx
@@ -211,7 +211,7 @@
           <a:p>
             <a:fld id="{C1BED7E8-5420-4F73-BA32-34A7030FE7D8}" type="datetimeFigureOut">
               <a:rPr lang="en-US" smtClean="0"/>
-              <a:t>2/16/2026</a:t>
+              <a:t>2/17/2026</a:t>
             </a:fld>
             <a:endParaRPr lang="en-US"/>
           </a:p>
@@ -1873,7 +1873,7 @@
           <a:p>
             <a:fld id="{C198EE3F-C531-4F47-81BE-EB7857D8F039}" type="datetimeFigureOut">
               <a:rPr lang="en-US" smtClean="0"/>
-              <a:t>2/16/2026</a:t>
+              <a:t>2/17/2026</a:t>
             </a:fld>
             <a:endParaRPr lang="en-US"/>
           </a:p>
@@ -2071,7 +2071,7 @@
           <a:p>
             <a:fld id="{C198EE3F-C531-4F47-81BE-EB7857D8F039}" type="datetimeFigureOut">
               <a:rPr lang="en-US" smtClean="0"/>
-              <a:t>2/16/2026</a:t>
+              <a:t>2/17/2026</a:t>
             </a:fld>
             <a:endParaRPr lang="en-US"/>
           </a:p>
@@ -2279,7 +2279,7 @@
           <a:p>
             <a:fld id="{C198EE3F-C531-4F47-81BE-EB7857D8F039}" type="datetimeFigureOut">
               <a:rPr lang="en-US" smtClean="0"/>
-              <a:t>2/16/2026</a:t>
+              <a:t>2/17/2026</a:t>
             </a:fld>
             <a:endParaRPr lang="en-US"/>
           </a:p>
@@ -2477,7 +2477,7 @@
           <a:p>
             <a:fld id="{C198EE3F-C531-4F47-81BE-EB7857D8F039}" type="datetimeFigureOut">
               <a:rPr lang="en-US" smtClean="0"/>
-              <a:t>2/16/2026</a:t>
+              <a:t>2/17/2026</a:t>
             </a:fld>
             <a:endParaRPr lang="en-US"/>
           </a:p>
@@ -2752,7 +2752,7 @@
           <a:p>
             <a:fld id="{C198EE3F-C531-4F47-81BE-EB7857D8F039}" type="datetimeFigureOut">
               <a:rPr lang="en-US" smtClean="0"/>
-              <a:t>2/16/2026</a:t>
+              <a:t>2/17/2026</a:t>
             </a:fld>
             <a:endParaRPr lang="en-US"/>
           </a:p>
@@ -3017,7 +3017,7 @@
           <a:p>
             <a:fld id="{C198EE3F-C531-4F47-81BE-EB7857D8F039}" type="datetimeFigureOut">
               <a:rPr lang="en-US" smtClean="0"/>
-              <a:t>2/16/2026</a:t>
+              <a:t>2/17/2026</a:t>
             </a:fld>
             <a:endParaRPr lang="en-US"/>
           </a:p>
@@ -3429,7 +3429,7 @@
           <a:p>
             <a:fld id="{C198EE3F-C531-4F47-81BE-EB7857D8F039}" type="datetimeFigureOut">
               <a:rPr lang="en-US" smtClean="0"/>
-              <a:t>2/16/2026</a:t>
+              <a:t>2/17/2026</a:t>
             </a:fld>
             <a:endParaRPr lang="en-US"/>
           </a:p>
@@ -3570,7 +3570,7 @@
           <a:p>
             <a:fld id="{C198EE3F-C531-4F47-81BE-EB7857D8F039}" type="datetimeFigureOut">
               <a:rPr lang="en-US" smtClean="0"/>
-              <a:t>2/16/2026</a:t>
+              <a:t>2/17/2026</a:t>
             </a:fld>
             <a:endParaRPr lang="en-US"/>
           </a:p>
@@ -3683,7 +3683,7 @@
           <a:p>
             <a:fld id="{C198EE3F-C531-4F47-81BE-EB7857D8F039}" type="datetimeFigureOut">
               <a:rPr lang="en-US" smtClean="0"/>
-              <a:t>2/16/2026</a:t>
+              <a:t>2/17/2026</a:t>
             </a:fld>
             <a:endParaRPr lang="en-US"/>
           </a:p>
@@ -3994,7 +3994,7 @@
           <a:p>
             <a:fld id="{C198EE3F-C531-4F47-81BE-EB7857D8F039}" type="datetimeFigureOut">
               <a:rPr lang="en-US" smtClean="0"/>
-              <a:t>2/16/2026</a:t>
+              <a:t>2/17/2026</a:t>
             </a:fld>
             <a:endParaRPr lang="en-US"/>
           </a:p>
@@ -4282,7 +4282,7 @@
           <a:p>
             <a:fld id="{C198EE3F-C531-4F47-81BE-EB7857D8F039}" type="datetimeFigureOut">
               <a:rPr lang="en-US" smtClean="0"/>
-              <a:t>2/16/2026</a:t>
+              <a:t>2/17/2026</a:t>
             </a:fld>
             <a:endParaRPr lang="en-US"/>
           </a:p>
@@ -4523,7 +4523,7 @@
           <a:p>
             <a:fld id="{C198EE3F-C531-4F47-81BE-EB7857D8F039}" type="datetimeFigureOut">
               <a:rPr lang="en-US" smtClean="0"/>
-              <a:t>2/16/2026</a:t>
+              <a:t>2/17/2026</a:t>
             </a:fld>
             <a:endParaRPr lang="en-US"/>
           </a:p>
@@ -4940,228 +4940,236 @@
           <a:chExt cx="0" cy="0"/>
         </a:xfrm>
       </p:grpSpPr>
+      <p:sp>
+        <p:nvSpPr>
+          <p:cNvPr id="4" name="TextBox 3">
+            <a:extLst>
+              <a:ext uri="{FF2B5EF4-FFF2-40B4-BE49-F238E27FC236}">
+                <a16:creationId xmlns:a16="http://schemas.microsoft.com/office/drawing/2014/main" id="{A6C65C56-0737-6750-E644-CD750C5836DE}"/>
+              </a:ext>
+            </a:extLst>
+          </p:cNvPr>
+          <p:cNvSpPr txBox="1"/>
+          <p:nvPr/>
+        </p:nvSpPr>
+        <p:spPr>
+          <a:xfrm>
+            <a:off x="147484" y="1543664"/>
+            <a:ext cx="11968316" cy="5693866"/>
+          </a:xfrm>
+          <a:prstGeom prst="rect">
+            <a:avLst/>
+          </a:prstGeom>
+          <a:noFill/>
+        </p:spPr>
+        <p:txBody>
+          <a:bodyPr wrap="square">
+            <a:spAutoFit/>
+          </a:bodyPr>
+          <a:lstStyle/>
+          <a:p>
+            <a:pPr algn="ctr"/>
+            <a:r>
+              <a:rPr lang="en-US" sz="2600" dirty="0">
+                <a:latin typeface="Times New Roman" panose="02020603050405020304" pitchFamily="18" charset="0"/>
+                <a:cs typeface="Times New Roman" panose="02020603050405020304" pitchFamily="18" charset="0"/>
+              </a:rPr>
+              <a:t>IBM Project Presentation</a:t>
+            </a:r>
+          </a:p>
+          <a:p>
+            <a:pPr algn="ctr"/>
+            <a:r>
+              <a:rPr lang="en-US" sz="2600" dirty="0">
+                <a:latin typeface="Times New Roman" panose="02020603050405020304" pitchFamily="18" charset="0"/>
+                <a:cs typeface="Times New Roman" panose="02020603050405020304" pitchFamily="18" charset="0"/>
+              </a:rPr>
+              <a:t>on</a:t>
+            </a:r>
+          </a:p>
+          <a:p>
+            <a:pPr algn="ctr"/>
+            <a:r>
+              <a:rPr lang="en-US" sz="2600" dirty="0">
+                <a:latin typeface="Times New Roman" panose="02020603050405020304" pitchFamily="18" charset="0"/>
+                <a:cs typeface="Times New Roman" panose="02020603050405020304" pitchFamily="18" charset="0"/>
+              </a:rPr>
+              <a:t>“Proactive Equipment Care using Analytics with Cloud - Cloud Integrated Analytics” </a:t>
+            </a:r>
+          </a:p>
+          <a:p>
+            <a:pPr algn="ctr"/>
+            <a:r>
+              <a:rPr lang="en-US" sz="2600" dirty="0">
+                <a:latin typeface="Times New Roman" panose="02020603050405020304" pitchFamily="18" charset="0"/>
+                <a:cs typeface="Times New Roman" panose="02020603050405020304" pitchFamily="18" charset="0"/>
+              </a:rPr>
+              <a:t>By </a:t>
+            </a:r>
+          </a:p>
+          <a:p>
+            <a:pPr algn="ctr"/>
+            <a:r>
+              <a:rPr lang="en-US" sz="2600" dirty="0">
+                <a:latin typeface="Times New Roman" panose="02020603050405020304" pitchFamily="18" charset="0"/>
+                <a:cs typeface="Times New Roman" panose="02020603050405020304" pitchFamily="18" charset="0"/>
+              </a:rPr>
+              <a:t>Group ID: G03</a:t>
+            </a:r>
+          </a:p>
+          <a:p>
+            <a:pPr algn="ctr"/>
+            <a:r>
+              <a:rPr lang="en-US" sz="2600" dirty="0">
+                <a:latin typeface="Times New Roman" panose="02020603050405020304" pitchFamily="18" charset="0"/>
+                <a:cs typeface="Times New Roman" panose="02020603050405020304" pitchFamily="18" charset="0"/>
+              </a:rPr>
+              <a:t>Team Members Name &amp; Enrollment No:</a:t>
+            </a:r>
+          </a:p>
+          <a:p>
+            <a:pPr algn="ctr"/>
+            <a:r>
+              <a:rPr lang="en-US" sz="2600" dirty="0">
+                <a:latin typeface="Times New Roman" panose="02020603050405020304" pitchFamily="18" charset="0"/>
+                <a:cs typeface="Times New Roman" panose="02020603050405020304" pitchFamily="18" charset="0"/>
+              </a:rPr>
+              <a:t>Patel Megh(22162121011)</a:t>
+            </a:r>
+          </a:p>
+          <a:p>
+            <a:pPr algn="ctr"/>
+            <a:r>
+              <a:rPr lang="en-US" sz="2600" dirty="0">
+                <a:latin typeface="Times New Roman" panose="02020603050405020304" pitchFamily="18" charset="0"/>
+                <a:cs typeface="Times New Roman" panose="02020603050405020304" pitchFamily="18" charset="0"/>
+              </a:rPr>
+              <a:t>Prajapati Pratham(22162171023)</a:t>
+            </a:r>
+          </a:p>
+          <a:p>
+            <a:pPr algn="ctr"/>
+            <a:r>
+              <a:rPr lang="en-US" sz="2600" dirty="0">
+                <a:latin typeface="Times New Roman" panose="02020603050405020304" pitchFamily="18" charset="0"/>
+                <a:cs typeface="Times New Roman" panose="02020603050405020304" pitchFamily="18" charset="0"/>
+              </a:rPr>
+              <a:t>Patel Tirth(22162101016)</a:t>
+            </a:r>
+          </a:p>
+          <a:p>
+            <a:pPr algn="ctr"/>
+            <a:r>
+              <a:rPr lang="en-US" sz="2600" dirty="0">
+                <a:latin typeface="Times New Roman" panose="02020603050405020304" pitchFamily="18" charset="0"/>
+                <a:cs typeface="Times New Roman" panose="02020603050405020304" pitchFamily="18" charset="0"/>
+              </a:rPr>
+              <a:t> Under The guidance of </a:t>
+            </a:r>
+          </a:p>
+          <a:p>
+            <a:pPr algn="ctr"/>
+            <a:r>
+              <a:rPr lang="en-US" sz="2600" dirty="0">
+                <a:latin typeface="Times New Roman" panose="02020603050405020304" pitchFamily="18" charset="0"/>
+                <a:cs typeface="Times New Roman" panose="02020603050405020304" pitchFamily="18" charset="0"/>
+              </a:rPr>
+              <a:t>Prof. Umesh </a:t>
+            </a:r>
+            <a:r>
+              <a:rPr lang="en-US" sz="2600" dirty="0" err="1">
+                <a:latin typeface="Times New Roman" panose="02020603050405020304" pitchFamily="18" charset="0"/>
+                <a:cs typeface="Times New Roman" panose="02020603050405020304" pitchFamily="18" charset="0"/>
+              </a:rPr>
+              <a:t>Lakhtariya</a:t>
+            </a:r>
+            <a:r>
+              <a:rPr lang="en-US" sz="2600" dirty="0">
+                <a:latin typeface="Times New Roman" panose="02020603050405020304" pitchFamily="18" charset="0"/>
+                <a:cs typeface="Times New Roman" panose="02020603050405020304" pitchFamily="18" charset="0"/>
+              </a:rPr>
+              <a:t> /Mr. Anoj Dixit</a:t>
+            </a:r>
+          </a:p>
+          <a:p>
+            <a:pPr algn="ctr"/>
+            <a:r>
+              <a:rPr lang="en-US" sz="2600" dirty="0">
+                <a:latin typeface="Times New Roman" panose="02020603050405020304" pitchFamily="18" charset="0"/>
+                <a:cs typeface="Times New Roman" panose="02020603050405020304" pitchFamily="18" charset="0"/>
+              </a:rPr>
+              <a:t>Institute Of Computer Technology, Ganpat University</a:t>
+            </a:r>
+          </a:p>
+          <a:p>
+            <a:pPr algn="ctr"/>
+            <a:r>
+              <a:rPr lang="en-US" sz="2600" dirty="0">
+                <a:latin typeface="Times New Roman" panose="02020603050405020304" pitchFamily="18" charset="0"/>
+                <a:cs typeface="Times New Roman" panose="02020603050405020304" pitchFamily="18" charset="0"/>
+              </a:rPr>
+              <a:t>Date:- 21</a:t>
+            </a:r>
+            <a:r>
+              <a:rPr lang="en-US" sz="2600" baseline="30000" dirty="0">
+                <a:latin typeface="Times New Roman" panose="02020603050405020304" pitchFamily="18" charset="0"/>
+                <a:cs typeface="Times New Roman" panose="02020603050405020304" pitchFamily="18" charset="0"/>
+              </a:rPr>
+              <a:t>th</a:t>
+            </a:r>
+            <a:r>
+              <a:rPr lang="en-US" sz="2600" dirty="0">
+                <a:latin typeface="Times New Roman" panose="02020603050405020304" pitchFamily="18" charset="0"/>
+                <a:cs typeface="Times New Roman" panose="02020603050405020304" pitchFamily="18" charset="0"/>
+              </a:rPr>
+              <a:t> February 2026</a:t>
+            </a:r>
+          </a:p>
+          <a:p>
+            <a:pPr algn="ctr"/>
+            <a:endParaRPr lang="en-US" sz="2600" dirty="0">
+              <a:latin typeface="Times New Roman" panose="02020603050405020304" pitchFamily="18" charset="0"/>
+              <a:cs typeface="Times New Roman" panose="02020603050405020304" pitchFamily="18" charset="0"/>
+            </a:endParaRPr>
+          </a:p>
+        </p:txBody>
+      </p:sp>
       <p:pic>
         <p:nvPicPr>
-          <p:cNvPr id="2" name="Picture 1">
-            <a:extLst>
-              <a:ext uri="{FF2B5EF4-FFF2-40B4-BE49-F238E27FC236}">
-                <a16:creationId xmlns:a16="http://schemas.microsoft.com/office/drawing/2014/main" id="{ACD8AACB-CA4F-D599-14E0-02AA951B4E80}"/>
-              </a:ext>
-            </a:extLst>
-          </p:cNvPr>
-          <p:cNvPicPr/>
+          <p:cNvPr id="7" name="Picture 6">
+            <a:extLst>
+              <a:ext uri="{FF2B5EF4-FFF2-40B4-BE49-F238E27FC236}">
+                <a16:creationId xmlns:a16="http://schemas.microsoft.com/office/drawing/2014/main" id="{CE7F484A-26CD-F930-A209-2D31F30DB3BC}"/>
+              </a:ext>
+            </a:extLst>
+          </p:cNvPr>
+          <p:cNvPicPr>
+            <a:picLocks noChangeAspect="1"/>
+          </p:cNvPicPr>
           <p:nvPr/>
         </p:nvPicPr>
         <p:blipFill>
-          <a:blip r:embed="rId2"/>
+          <a:blip r:embed="rId2">
+            <a:extLst>
+              <a:ext uri="{28A0092B-C50C-407E-A947-70E740481C1C}">
+                <a14:useLocalDpi xmlns:a14="http://schemas.microsoft.com/office/drawing/2010/main" val="0"/>
+              </a:ext>
+            </a:extLst>
+          </a:blip>
           <a:stretch>
             <a:fillRect/>
           </a:stretch>
         </p:blipFill>
         <p:spPr>
           <a:xfrm>
-            <a:off x="3286125" y="129223"/>
-            <a:ext cx="5619750" cy="982980"/>
+            <a:off x="3524865" y="69606"/>
+            <a:ext cx="5142270" cy="1396192"/>
           </a:xfrm>
           <a:prstGeom prst="rect">
             <a:avLst/>
           </a:prstGeom>
         </p:spPr>
       </p:pic>
-      <p:sp>
-        <p:nvSpPr>
-          <p:cNvPr id="4" name="TextBox 3">
-            <a:extLst>
-              <a:ext uri="{FF2B5EF4-FFF2-40B4-BE49-F238E27FC236}">
-                <a16:creationId xmlns:a16="http://schemas.microsoft.com/office/drawing/2014/main" id="{A6C65C56-0737-6750-E644-CD750C5836DE}"/>
-              </a:ext>
-            </a:extLst>
-          </p:cNvPr>
-          <p:cNvSpPr txBox="1"/>
-          <p:nvPr/>
-        </p:nvSpPr>
-        <p:spPr>
-          <a:xfrm>
-            <a:off x="76200" y="1465798"/>
-            <a:ext cx="12039600" cy="5693866"/>
-          </a:xfrm>
-          <a:prstGeom prst="rect">
-            <a:avLst/>
-          </a:prstGeom>
-          <a:noFill/>
-        </p:spPr>
-        <p:txBody>
-          <a:bodyPr wrap="square">
-            <a:spAutoFit/>
-          </a:bodyPr>
-          <a:lstStyle/>
-          <a:p>
-            <a:pPr algn="ctr"/>
-            <a:r>
-              <a:rPr lang="en-US" sz="2600" dirty="0">
-                <a:latin typeface="Times New Roman" panose="02020603050405020304" pitchFamily="18" charset="0"/>
-                <a:cs typeface="Times New Roman" panose="02020603050405020304" pitchFamily="18" charset="0"/>
-              </a:rPr>
-              <a:t>IBM Project Presentation</a:t>
-            </a:r>
-          </a:p>
-          <a:p>
-            <a:pPr algn="ctr"/>
-            <a:r>
-              <a:rPr lang="en-US" sz="2600" dirty="0">
-                <a:latin typeface="Times New Roman" panose="02020603050405020304" pitchFamily="18" charset="0"/>
-                <a:cs typeface="Times New Roman" panose="02020603050405020304" pitchFamily="18" charset="0"/>
-              </a:rPr>
-              <a:t>on</a:t>
-            </a:r>
-          </a:p>
-          <a:p>
-            <a:pPr algn="ctr"/>
-            <a:r>
-              <a:rPr lang="en-US" sz="2600" dirty="0">
-                <a:latin typeface="Times New Roman" panose="02020603050405020304" pitchFamily="18" charset="0"/>
-                <a:cs typeface="Times New Roman" panose="02020603050405020304" pitchFamily="18" charset="0"/>
-              </a:rPr>
-              <a:t>“Proactive Equipment Care using Analytics with Cloud - Cloud Integrated Analytics” </a:t>
-            </a:r>
-          </a:p>
-          <a:p>
-            <a:pPr algn="ctr"/>
-            <a:r>
-              <a:rPr lang="en-US" sz="2600" dirty="0">
-                <a:latin typeface="Times New Roman" panose="02020603050405020304" pitchFamily="18" charset="0"/>
-                <a:cs typeface="Times New Roman" panose="02020603050405020304" pitchFamily="18" charset="0"/>
-              </a:rPr>
-              <a:t>By </a:t>
-            </a:r>
-          </a:p>
-          <a:p>
-            <a:pPr algn="ctr"/>
-            <a:r>
-              <a:rPr lang="en-US" sz="2600" dirty="0">
-                <a:latin typeface="Times New Roman" panose="02020603050405020304" pitchFamily="18" charset="0"/>
-                <a:cs typeface="Times New Roman" panose="02020603050405020304" pitchFamily="18" charset="0"/>
-              </a:rPr>
-              <a:t>Group ID: G03</a:t>
-            </a:r>
-          </a:p>
-          <a:p>
-            <a:pPr algn="ctr"/>
-            <a:r>
-              <a:rPr lang="en-US" sz="2600" dirty="0">
-                <a:latin typeface="Times New Roman" panose="02020603050405020304" pitchFamily="18" charset="0"/>
-                <a:cs typeface="Times New Roman" panose="02020603050405020304" pitchFamily="18" charset="0"/>
-              </a:rPr>
-              <a:t>Team Members Name &amp; Enrollment No:</a:t>
-            </a:r>
-          </a:p>
-          <a:p>
-            <a:pPr algn="ctr"/>
-            <a:r>
-              <a:rPr lang="en-US" sz="2600" dirty="0">
-                <a:latin typeface="Times New Roman" panose="02020603050405020304" pitchFamily="18" charset="0"/>
-                <a:cs typeface="Times New Roman" panose="02020603050405020304" pitchFamily="18" charset="0"/>
-              </a:rPr>
-              <a:t>Patel Megh(22162121011)</a:t>
-            </a:r>
-          </a:p>
-          <a:p>
-            <a:pPr algn="ctr"/>
-            <a:r>
-              <a:rPr lang="en-US" sz="2600" dirty="0">
-                <a:latin typeface="Times New Roman" panose="02020603050405020304" pitchFamily="18" charset="0"/>
-                <a:cs typeface="Times New Roman" panose="02020603050405020304" pitchFamily="18" charset="0"/>
-              </a:rPr>
-              <a:t>Prajapati Pratham(22162171023)</a:t>
-            </a:r>
-          </a:p>
-          <a:p>
-            <a:pPr algn="ctr"/>
-            <a:r>
-              <a:rPr lang="en-US" sz="2600" dirty="0">
-                <a:latin typeface="Times New Roman" panose="02020603050405020304" pitchFamily="18" charset="0"/>
-                <a:cs typeface="Times New Roman" panose="02020603050405020304" pitchFamily="18" charset="0"/>
-              </a:rPr>
-              <a:t>Patel Tirth(22162101016)</a:t>
-            </a:r>
-          </a:p>
-          <a:p>
-            <a:pPr algn="ctr"/>
-            <a:r>
-              <a:rPr lang="en-US" sz="2600" dirty="0">
-                <a:latin typeface="Times New Roman" panose="02020603050405020304" pitchFamily="18" charset="0"/>
-                <a:cs typeface="Times New Roman" panose="02020603050405020304" pitchFamily="18" charset="0"/>
-              </a:rPr>
-              <a:t> Under The guidance of </a:t>
-            </a:r>
-          </a:p>
-          <a:p>
-            <a:pPr algn="ctr"/>
-            <a:r>
-              <a:rPr lang="en-US" sz="2600" dirty="0">
-                <a:latin typeface="Times New Roman" panose="02020603050405020304" pitchFamily="18" charset="0"/>
-                <a:cs typeface="Times New Roman" panose="02020603050405020304" pitchFamily="18" charset="0"/>
-              </a:rPr>
-              <a:t>Prof. Umesh </a:t>
-            </a:r>
-            <a:r>
-              <a:rPr lang="en-US" sz="2600" dirty="0" err="1">
-                <a:latin typeface="Times New Roman" panose="02020603050405020304" pitchFamily="18" charset="0"/>
-                <a:cs typeface="Times New Roman" panose="02020603050405020304" pitchFamily="18" charset="0"/>
-              </a:rPr>
-              <a:t>Lakhtariya</a:t>
-            </a:r>
-            <a:r>
-              <a:rPr lang="en-US" sz="2600" dirty="0">
-                <a:latin typeface="Times New Roman" panose="02020603050405020304" pitchFamily="18" charset="0"/>
-                <a:cs typeface="Times New Roman" panose="02020603050405020304" pitchFamily="18" charset="0"/>
-              </a:rPr>
-              <a:t> /Mr. Anoj Dixit</a:t>
-            </a:r>
-          </a:p>
-          <a:p>
-            <a:pPr algn="ctr"/>
-            <a:r>
-              <a:rPr lang="en-US" sz="2600" dirty="0">
-                <a:latin typeface="Times New Roman" panose="02020603050405020304" pitchFamily="18" charset="0"/>
-                <a:cs typeface="Times New Roman" panose="02020603050405020304" pitchFamily="18" charset="0"/>
-              </a:rPr>
-              <a:t>Institute Of Computer Technology, Ganpat University</a:t>
-            </a:r>
-          </a:p>
-          <a:p>
-            <a:pPr algn="ctr"/>
-            <a:r>
-              <a:rPr lang="en-US" sz="2600" dirty="0">
-                <a:latin typeface="Times New Roman" panose="02020603050405020304" pitchFamily="18" charset="0"/>
-                <a:cs typeface="Times New Roman" panose="02020603050405020304" pitchFamily="18" charset="0"/>
-              </a:rPr>
-              <a:t>Date:- 21</a:t>
-            </a:r>
-            <a:r>
-              <a:rPr lang="en-US" sz="2600" baseline="30000" dirty="0">
-                <a:latin typeface="Times New Roman" panose="02020603050405020304" pitchFamily="18" charset="0"/>
-                <a:cs typeface="Times New Roman" panose="02020603050405020304" pitchFamily="18" charset="0"/>
-              </a:rPr>
-              <a:t>th</a:t>
-            </a:r>
-            <a:r>
-              <a:rPr lang="en-US" sz="2600" dirty="0">
-                <a:latin typeface="Times New Roman" panose="02020603050405020304" pitchFamily="18" charset="0"/>
-                <a:cs typeface="Times New Roman" panose="02020603050405020304" pitchFamily="18" charset="0"/>
-              </a:rPr>
-              <a:t> February 2026</a:t>
-            </a:r>
-          </a:p>
-          <a:p>
-            <a:pPr algn="ctr"/>
-            <a:endParaRPr lang="en-US" sz="2600" dirty="0">
-              <a:latin typeface="Times New Roman" panose="02020603050405020304" pitchFamily="18" charset="0"/>
-              <a:cs typeface="Times New Roman" panose="02020603050405020304" pitchFamily="18" charset="0"/>
-            </a:endParaRPr>
-          </a:p>
-        </p:txBody>
-      </p:sp>
     </p:spTree>
     <p:extLst>
       <p:ext uri="{BB962C8B-B14F-4D97-AF65-F5344CB8AC3E}">

</xml_diff>

<commit_message>
Edited Report and PPT as per suggestion
</commit_message>
<xml_diff>
--- a/docs/Clg 1st review.pptx
+++ b/docs/Clg 1st review.pptx
@@ -211,7 +211,7 @@
           <a:p>
             <a:fld id="{C1BED7E8-5420-4F73-BA32-34A7030FE7D8}" type="datetimeFigureOut">
               <a:rPr lang="en-US" smtClean="0"/>
-              <a:t>2/17/2026</a:t>
+              <a:t>2/19/2026</a:t>
             </a:fld>
             <a:endParaRPr lang="en-US"/>
           </a:p>
@@ -1873,7 +1873,7 @@
           <a:p>
             <a:fld id="{C198EE3F-C531-4F47-81BE-EB7857D8F039}" type="datetimeFigureOut">
               <a:rPr lang="en-US" smtClean="0"/>
-              <a:t>2/17/2026</a:t>
+              <a:t>2/19/2026</a:t>
             </a:fld>
             <a:endParaRPr lang="en-US"/>
           </a:p>
@@ -2071,7 +2071,7 @@
           <a:p>
             <a:fld id="{C198EE3F-C531-4F47-81BE-EB7857D8F039}" type="datetimeFigureOut">
               <a:rPr lang="en-US" smtClean="0"/>
-              <a:t>2/17/2026</a:t>
+              <a:t>2/19/2026</a:t>
             </a:fld>
             <a:endParaRPr lang="en-US"/>
           </a:p>
@@ -2279,7 +2279,7 @@
           <a:p>
             <a:fld id="{C198EE3F-C531-4F47-81BE-EB7857D8F039}" type="datetimeFigureOut">
               <a:rPr lang="en-US" smtClean="0"/>
-              <a:t>2/17/2026</a:t>
+              <a:t>2/19/2026</a:t>
             </a:fld>
             <a:endParaRPr lang="en-US"/>
           </a:p>
@@ -2477,7 +2477,7 @@
           <a:p>
             <a:fld id="{C198EE3F-C531-4F47-81BE-EB7857D8F039}" type="datetimeFigureOut">
               <a:rPr lang="en-US" smtClean="0"/>
-              <a:t>2/17/2026</a:t>
+              <a:t>2/19/2026</a:t>
             </a:fld>
             <a:endParaRPr lang="en-US"/>
           </a:p>
@@ -2752,7 +2752,7 @@
           <a:p>
             <a:fld id="{C198EE3F-C531-4F47-81BE-EB7857D8F039}" type="datetimeFigureOut">
               <a:rPr lang="en-US" smtClean="0"/>
-              <a:t>2/17/2026</a:t>
+              <a:t>2/19/2026</a:t>
             </a:fld>
             <a:endParaRPr lang="en-US"/>
           </a:p>
@@ -3017,7 +3017,7 @@
           <a:p>
             <a:fld id="{C198EE3F-C531-4F47-81BE-EB7857D8F039}" type="datetimeFigureOut">
               <a:rPr lang="en-US" smtClean="0"/>
-              <a:t>2/17/2026</a:t>
+              <a:t>2/19/2026</a:t>
             </a:fld>
             <a:endParaRPr lang="en-US"/>
           </a:p>
@@ -3429,7 +3429,7 @@
           <a:p>
             <a:fld id="{C198EE3F-C531-4F47-81BE-EB7857D8F039}" type="datetimeFigureOut">
               <a:rPr lang="en-US" smtClean="0"/>
-              <a:t>2/17/2026</a:t>
+              <a:t>2/19/2026</a:t>
             </a:fld>
             <a:endParaRPr lang="en-US"/>
           </a:p>
@@ -3570,7 +3570,7 @@
           <a:p>
             <a:fld id="{C198EE3F-C531-4F47-81BE-EB7857D8F039}" type="datetimeFigureOut">
               <a:rPr lang="en-US" smtClean="0"/>
-              <a:t>2/17/2026</a:t>
+              <a:t>2/19/2026</a:t>
             </a:fld>
             <a:endParaRPr lang="en-US"/>
           </a:p>
@@ -3683,7 +3683,7 @@
           <a:p>
             <a:fld id="{C198EE3F-C531-4F47-81BE-EB7857D8F039}" type="datetimeFigureOut">
               <a:rPr lang="en-US" smtClean="0"/>
-              <a:t>2/17/2026</a:t>
+              <a:t>2/19/2026</a:t>
             </a:fld>
             <a:endParaRPr lang="en-US"/>
           </a:p>
@@ -3994,7 +3994,7 @@
           <a:p>
             <a:fld id="{C198EE3F-C531-4F47-81BE-EB7857D8F039}" type="datetimeFigureOut">
               <a:rPr lang="en-US" smtClean="0"/>
-              <a:t>2/17/2026</a:t>
+              <a:t>2/19/2026</a:t>
             </a:fld>
             <a:endParaRPr lang="en-US"/>
           </a:p>
@@ -4282,7 +4282,7 @@
           <a:p>
             <a:fld id="{C198EE3F-C531-4F47-81BE-EB7857D8F039}" type="datetimeFigureOut">
               <a:rPr lang="en-US" smtClean="0"/>
-              <a:t>2/17/2026</a:t>
+              <a:t>2/19/2026</a:t>
             </a:fld>
             <a:endParaRPr lang="en-US"/>
           </a:p>
@@ -4523,7 +4523,7 @@
           <a:p>
             <a:fld id="{C198EE3F-C531-4F47-81BE-EB7857D8F039}" type="datetimeFigureOut">
               <a:rPr lang="en-US" smtClean="0"/>
-              <a:t>2/17/2026</a:t>
+              <a:t>2/19/2026</a:t>
             </a:fld>
             <a:endParaRPr lang="en-US"/>
           </a:p>
@@ -5508,7 +5508,7 @@
         </p:nvSpPr>
         <p:spPr>
           <a:xfrm>
-            <a:off x="648929" y="1522934"/>
+            <a:off x="648929" y="1434444"/>
             <a:ext cx="11277599" cy="923330"/>
           </a:xfrm>
           <a:prstGeom prst="rect">
@@ -5664,7 +5664,7 @@
           </a:bodyPr>
           <a:lstStyle/>
           <a:p>
-            <a:pPr marL="342900" indent="-342900">
+            <a:pPr marL="342900" indent="-342900" algn="just">
               <a:buFont typeface="Wingdings" panose="05000000000000000000" pitchFamily="2" charset="2"/>
               <a:buChar char="Ø"/>
             </a:pPr>
@@ -5677,7 +5677,7 @@
             </a:r>
           </a:p>
           <a:p>
-            <a:pPr marL="342900" indent="-342900">
+            <a:pPr marL="342900" indent="-342900" algn="just">
               <a:buFont typeface="Wingdings" panose="05000000000000000000" pitchFamily="2" charset="2"/>
               <a:buChar char="ü"/>
             </a:pPr>
@@ -5690,13 +5690,14 @@
             </a:r>
           </a:p>
           <a:p>
+            <a:pPr algn="just"/>
             <a:endParaRPr lang="en-US" sz="2000" dirty="0">
               <a:latin typeface="Times New Roman" panose="02020603050405020304" pitchFamily="18" charset="0"/>
               <a:cs typeface="Times New Roman" panose="02020603050405020304" pitchFamily="18" charset="0"/>
             </a:endParaRPr>
           </a:p>
           <a:p>
-            <a:pPr marL="342900" indent="-342900">
+            <a:pPr marL="342900" indent="-342900" algn="just">
               <a:buFont typeface="Wingdings" panose="05000000000000000000" pitchFamily="2" charset="2"/>
               <a:buChar char="Ø"/>
             </a:pPr>
@@ -5709,7 +5710,7 @@
             </a:r>
           </a:p>
           <a:p>
-            <a:pPr marL="342900" indent="-342900">
+            <a:pPr marL="342900" indent="-342900" algn="just">
               <a:buFont typeface="Wingdings" panose="05000000000000000000" pitchFamily="2" charset="2"/>
               <a:buChar char="ü"/>
             </a:pPr>
@@ -5722,7 +5723,7 @@
             </a:r>
           </a:p>
           <a:p>
-            <a:pPr marL="342900" indent="-342900">
+            <a:pPr marL="342900" indent="-342900" algn="just">
               <a:buFont typeface="Wingdings" panose="05000000000000000000" pitchFamily="2" charset="2"/>
               <a:buChar char="Ø"/>
             </a:pPr>
@@ -5732,7 +5733,7 @@
             </a:endParaRPr>
           </a:p>
           <a:p>
-            <a:pPr marL="342900" indent="-342900">
+            <a:pPr marL="342900" indent="-342900" algn="just">
               <a:buFont typeface="Wingdings" panose="05000000000000000000" pitchFamily="2" charset="2"/>
               <a:buChar char="Ø"/>
             </a:pPr>
@@ -5745,7 +5746,7 @@
             </a:r>
           </a:p>
           <a:p>
-            <a:pPr marL="342900" indent="-342900">
+            <a:pPr marL="342900" indent="-342900" algn="just">
               <a:buFont typeface="Wingdings" panose="05000000000000000000" pitchFamily="2" charset="2"/>
               <a:buChar char="ü"/>
             </a:pPr>
@@ -5758,7 +5759,7 @@
             </a:r>
           </a:p>
           <a:p>
-            <a:pPr marL="342900" indent="-342900">
+            <a:pPr marL="342900" indent="-342900" algn="just">
               <a:buFont typeface="Wingdings" panose="05000000000000000000" pitchFamily="2" charset="2"/>
               <a:buChar char="Ø"/>
             </a:pPr>
@@ -5768,7 +5769,7 @@
             </a:endParaRPr>
           </a:p>
           <a:p>
-            <a:pPr marL="342900" indent="-342900">
+            <a:pPr marL="342900" indent="-342900" algn="just">
               <a:buFont typeface="Wingdings" panose="05000000000000000000" pitchFamily="2" charset="2"/>
               <a:buChar char="Ø"/>
             </a:pPr>
@@ -5781,7 +5782,7 @@
             </a:r>
           </a:p>
           <a:p>
-            <a:pPr marL="342900" indent="-342900">
+            <a:pPr marL="342900" indent="-342900" algn="just">
               <a:buFont typeface="Wingdings" panose="05000000000000000000" pitchFamily="2" charset="2"/>
               <a:buChar char="ü"/>
             </a:pPr>
@@ -5794,7 +5795,7 @@
             </a:r>
           </a:p>
           <a:p>
-            <a:pPr marL="342900" indent="-342900">
+            <a:pPr marL="342900" indent="-342900" algn="just">
               <a:buFont typeface="Wingdings" panose="05000000000000000000" pitchFamily="2" charset="2"/>
               <a:buChar char="Ø"/>
             </a:pPr>
@@ -5804,7 +5805,7 @@
             </a:endParaRPr>
           </a:p>
           <a:p>
-            <a:pPr marL="342900" indent="-342900">
+            <a:pPr marL="342900" indent="-342900" algn="just">
               <a:buFont typeface="Wingdings" panose="05000000000000000000" pitchFamily="2" charset="2"/>
               <a:buChar char="Ø"/>
             </a:pPr>
@@ -5817,7 +5818,7 @@
             </a:r>
           </a:p>
           <a:p>
-            <a:pPr marL="342900" indent="-342900">
+            <a:pPr marL="342900" indent="-342900" algn="just">
               <a:buFont typeface="Wingdings" panose="05000000000000000000" pitchFamily="2" charset="2"/>
               <a:buChar char="ü"/>
             </a:pPr>
@@ -5830,6 +5831,7 @@
             </a:r>
           </a:p>
           <a:p>
+            <a:pPr algn="just"/>
             <a:endParaRPr lang="en-US" sz="2000" dirty="0">
               <a:latin typeface="Times New Roman" panose="02020603050405020304" pitchFamily="18" charset="0"/>
               <a:cs typeface="Times New Roman" panose="02020603050405020304" pitchFamily="18" charset="0"/>
@@ -5936,7 +5938,7 @@
           </a:bodyPr>
           <a:lstStyle/>
           <a:p>
-            <a:pPr marL="342900" indent="-342900">
+            <a:pPr marL="342900" indent="-342900" algn="just">
               <a:buFont typeface="Wingdings" panose="05000000000000000000" pitchFamily="2" charset="2"/>
               <a:buChar char="Ø"/>
             </a:pPr>
@@ -5949,7 +5951,7 @@
             </a:r>
           </a:p>
           <a:p>
-            <a:pPr marL="342900" indent="-342900">
+            <a:pPr marL="342900" indent="-342900" algn="just">
               <a:buFont typeface="Wingdings" panose="05000000000000000000" pitchFamily="2" charset="2"/>
               <a:buChar char="Ø"/>
             </a:pPr>
@@ -5962,7 +5964,7 @@
             </a:r>
           </a:p>
           <a:p>
-            <a:pPr marL="342900" indent="-342900">
+            <a:pPr marL="342900" indent="-342900" algn="just">
               <a:buFont typeface="Wingdings" panose="05000000000000000000" pitchFamily="2" charset="2"/>
               <a:buChar char="Ø"/>
             </a:pPr>
@@ -5975,7 +5977,7 @@
             </a:r>
           </a:p>
           <a:p>
-            <a:pPr marL="342900" indent="-342900">
+            <a:pPr marL="342900" indent="-342900" algn="just">
               <a:buFont typeface="Wingdings" panose="05000000000000000000" pitchFamily="2" charset="2"/>
               <a:buChar char="Ø"/>
             </a:pPr>
@@ -5988,7 +5990,7 @@
             </a:r>
           </a:p>
           <a:p>
-            <a:pPr marL="342900" indent="-342900">
+            <a:pPr marL="342900" indent="-342900" algn="just">
               <a:buFont typeface="Wingdings" panose="05000000000000000000" pitchFamily="2" charset="2"/>
               <a:buChar char="Ø"/>
             </a:pPr>
@@ -6001,7 +6003,7 @@
             </a:r>
           </a:p>
           <a:p>
-            <a:pPr marL="342900" indent="-342900">
+            <a:pPr marL="342900" indent="-342900" algn="just">
               <a:buFont typeface="Wingdings" panose="05000000000000000000" pitchFamily="2" charset="2"/>
               <a:buChar char="Ø"/>
             </a:pPr>
@@ -6014,7 +6016,7 @@
             </a:r>
           </a:p>
           <a:p>
-            <a:pPr marL="342900" indent="-342900">
+            <a:pPr marL="342900" indent="-342900" algn="just">
               <a:buFont typeface="Wingdings" panose="05000000000000000000" pitchFamily="2" charset="2"/>
               <a:buChar char="Ø"/>
             </a:pPr>
@@ -6127,7 +6129,7 @@
           </a:bodyPr>
           <a:lstStyle/>
           <a:p>
-            <a:pPr marL="342900" indent="-342900">
+            <a:pPr marL="342900" indent="-342900" algn="just">
               <a:buFont typeface="Wingdings" panose="05000000000000000000" pitchFamily="2" charset="2"/>
               <a:buChar char="Ø"/>
             </a:pPr>
@@ -6140,7 +6142,7 @@
             </a:r>
           </a:p>
           <a:p>
-            <a:pPr marL="342900" indent="-342900">
+            <a:pPr marL="342900" indent="-342900" algn="just">
               <a:buFont typeface="Wingdings" panose="05000000000000000000" pitchFamily="2" charset="2"/>
               <a:buChar char="Ø"/>
             </a:pPr>
@@ -6153,7 +6155,7 @@
             </a:r>
           </a:p>
           <a:p>
-            <a:pPr marL="342900" indent="-342900">
+            <a:pPr marL="342900" indent="-342900" algn="just">
               <a:buFont typeface="Wingdings" panose="05000000000000000000" pitchFamily="2" charset="2"/>
               <a:buChar char="Ø"/>
             </a:pPr>
@@ -6166,7 +6168,7 @@
             </a:r>
           </a:p>
           <a:p>
-            <a:pPr marL="342900" indent="-342900">
+            <a:pPr marL="342900" indent="-342900" algn="just">
               <a:buFont typeface="Wingdings" panose="05000000000000000000" pitchFamily="2" charset="2"/>
               <a:buChar char="Ø"/>
             </a:pPr>
@@ -6179,7 +6181,7 @@
             </a:r>
           </a:p>
           <a:p>
-            <a:pPr marL="342900" indent="-342900">
+            <a:pPr marL="342900" indent="-342900" algn="just">
               <a:buFont typeface="Wingdings" panose="05000000000000000000" pitchFamily="2" charset="2"/>
               <a:buChar char="Ø"/>
             </a:pPr>
@@ -6292,7 +6294,7 @@
           </a:bodyPr>
           <a:lstStyle/>
           <a:p>
-            <a:pPr marL="342900" indent="-342900">
+            <a:pPr marL="342900" indent="-342900" algn="just">
               <a:buFont typeface="Wingdings" panose="05000000000000000000" pitchFamily="2" charset="2"/>
               <a:buChar char="Ø"/>
             </a:pPr>
@@ -6305,7 +6307,7 @@
             </a:r>
           </a:p>
           <a:p>
-            <a:pPr marL="342900" indent="-342900">
+            <a:pPr marL="342900" indent="-342900" algn="just">
               <a:buFont typeface="Wingdings" panose="05000000000000000000" pitchFamily="2" charset="2"/>
               <a:buChar char="Ø"/>
             </a:pPr>
@@ -6318,7 +6320,7 @@
             </a:r>
           </a:p>
           <a:p>
-            <a:pPr marL="342900" indent="-342900">
+            <a:pPr marL="342900" indent="-342900" algn="just">
               <a:buFont typeface="Wingdings" panose="05000000000000000000" pitchFamily="2" charset="2"/>
               <a:buChar char="Ø"/>
             </a:pPr>
@@ -6731,7 +6733,7 @@
           </a:bodyPr>
           <a:lstStyle/>
           <a:p>
-            <a:pPr marL="342900" indent="-342900">
+            <a:pPr marL="342900" indent="-342900" algn="just">
               <a:buFont typeface="Wingdings" panose="05000000000000000000" pitchFamily="2" charset="2"/>
               <a:buChar char="Ø"/>
             </a:pPr>
@@ -6745,7 +6747,7 @@
             </a:r>
           </a:p>
           <a:p>
-            <a:pPr marL="342900" indent="-342900">
+            <a:pPr marL="342900" indent="-342900" algn="just">
               <a:buFont typeface="Wingdings" panose="05000000000000000000" pitchFamily="2" charset="2"/>
               <a:buChar char="Ø"/>
             </a:pPr>
@@ -6759,7 +6761,7 @@
             </a:r>
           </a:p>
           <a:p>
-            <a:pPr marL="342900" indent="-342900">
+            <a:pPr marL="342900" indent="-342900" algn="just">
               <a:buFont typeface="Wingdings" panose="05000000000000000000" pitchFamily="2" charset="2"/>
               <a:buChar char="Ø"/>
             </a:pPr>
@@ -6773,7 +6775,7 @@
             </a:r>
           </a:p>
           <a:p>
-            <a:pPr marL="342900" indent="-342900">
+            <a:pPr marL="342900" indent="-342900" algn="just">
               <a:buFont typeface="Wingdings" panose="05000000000000000000" pitchFamily="2" charset="2"/>
               <a:buChar char="Ø"/>
             </a:pPr>
@@ -6787,7 +6789,7 @@
             </a:r>
           </a:p>
           <a:p>
-            <a:pPr marL="342900" indent="-342900">
+            <a:pPr marL="342900" indent="-342900" algn="just">
               <a:buFont typeface="Wingdings" panose="05000000000000000000" pitchFamily="2" charset="2"/>
               <a:buChar char="Ø"/>
             </a:pPr>
@@ -6895,7 +6897,7 @@
           </a:bodyPr>
           <a:lstStyle/>
           <a:p>
-            <a:pPr marL="342900" indent="-342900">
+            <a:pPr marL="342900" indent="-342900" algn="just">
               <a:buFont typeface="Wingdings" panose="05000000000000000000" pitchFamily="2" charset="2"/>
               <a:buChar char="Ø"/>
             </a:pPr>
@@ -6908,7 +6910,7 @@
             </a:r>
           </a:p>
           <a:p>
-            <a:pPr marL="342900" indent="-342900">
+            <a:pPr marL="342900" indent="-342900" algn="just">
               <a:buFont typeface="Wingdings" panose="05000000000000000000" pitchFamily="2" charset="2"/>
               <a:buChar char="ü"/>
             </a:pPr>
@@ -6921,7 +6923,7 @@
             </a:r>
           </a:p>
           <a:p>
-            <a:pPr marL="342900" indent="-342900">
+            <a:pPr marL="342900" indent="-342900" algn="just">
               <a:buFont typeface="Wingdings" panose="05000000000000000000" pitchFamily="2" charset="2"/>
               <a:buChar char="ü"/>
             </a:pPr>
@@ -6962,7 +6964,7 @@
             </a:r>
           </a:p>
           <a:p>
-            <a:pPr marL="342900" indent="-342900">
+            <a:pPr marL="342900" indent="-342900" algn="just">
               <a:buFont typeface="Wingdings" panose="05000000000000000000" pitchFamily="2" charset="2"/>
               <a:buChar char="ü"/>
             </a:pPr>
@@ -6975,7 +6977,7 @@
             </a:r>
           </a:p>
           <a:p>
-            <a:pPr marL="342900" indent="-342900">
+            <a:pPr marL="342900" indent="-342900" algn="just">
               <a:buFont typeface="Wingdings" panose="05000000000000000000" pitchFamily="2" charset="2"/>
               <a:buChar char="ü"/>
             </a:pPr>
@@ -6988,7 +6990,7 @@
             </a:r>
           </a:p>
           <a:p>
-            <a:pPr marL="342900" indent="-342900">
+            <a:pPr marL="342900" indent="-342900" algn="just">
               <a:buFont typeface="Wingdings" panose="05000000000000000000" pitchFamily="2" charset="2"/>
               <a:buChar char="ü"/>
             </a:pPr>
@@ -7030,6 +7032,7 @@
           </a:bodyPr>
           <a:lstStyle/>
           <a:p>
+            <a:pPr algn="just"/>
             <a:r>
               <a:rPr lang="en-US" sz="2000" dirty="0">
                 <a:latin typeface="Times New Roman" panose="02020603050405020304" pitchFamily="18" charset="0"/>
@@ -7039,6 +7042,7 @@
             </a:r>
           </a:p>
           <a:p>
+            <a:pPr algn="just"/>
             <a:endParaRPr lang="en-US" sz="2000" dirty="0">
               <a:latin typeface="Times New Roman" panose="02020603050405020304" pitchFamily="18" charset="0"/>
               <a:cs typeface="Times New Roman" panose="02020603050405020304" pitchFamily="18" charset="0"/>
@@ -7145,7 +7149,7 @@
           </a:bodyPr>
           <a:lstStyle/>
           <a:p>
-            <a:pPr marL="342900" indent="-342900">
+            <a:pPr marL="342900" indent="-342900" algn="just">
               <a:buFont typeface="Wingdings" panose="05000000000000000000" pitchFamily="2" charset="2"/>
               <a:buChar char="Ø"/>
             </a:pPr>
@@ -7158,7 +7162,7 @@
             </a:r>
           </a:p>
           <a:p>
-            <a:pPr marL="342900" indent="-342900">
+            <a:pPr marL="342900" indent="-342900" algn="just">
               <a:buFont typeface="Wingdings" panose="05000000000000000000" pitchFamily="2" charset="2"/>
               <a:buChar char="Ø"/>
             </a:pPr>
@@ -7171,7 +7175,7 @@
             </a:r>
           </a:p>
           <a:p>
-            <a:pPr marL="342900" indent="-342900">
+            <a:pPr marL="342900" indent="-342900" algn="just">
               <a:buFont typeface="Wingdings" panose="05000000000000000000" pitchFamily="2" charset="2"/>
               <a:buChar char="Ø"/>
             </a:pPr>
@@ -7184,7 +7188,7 @@
             </a:r>
           </a:p>
           <a:p>
-            <a:pPr marL="342900" indent="-342900">
+            <a:pPr marL="342900" indent="-342900" algn="just">
               <a:buFont typeface="Wingdings" panose="05000000000000000000" pitchFamily="2" charset="2"/>
               <a:buChar char="Ø"/>
             </a:pPr>
@@ -7197,7 +7201,7 @@
             </a:r>
           </a:p>
           <a:p>
-            <a:pPr marL="342900" indent="-342900">
+            <a:pPr marL="342900" indent="-342900" algn="just">
               <a:buFont typeface="Wingdings" panose="05000000000000000000" pitchFamily="2" charset="2"/>
               <a:buChar char="Ø"/>
             </a:pPr>
@@ -7210,7 +7214,7 @@
             </a:r>
           </a:p>
           <a:p>
-            <a:pPr marL="342900" indent="-342900">
+            <a:pPr marL="342900" indent="-342900" algn="just">
               <a:buFont typeface="Wingdings" panose="05000000000000000000" pitchFamily="2" charset="2"/>
               <a:buChar char="Ø"/>
             </a:pPr>
@@ -7223,7 +7227,7 @@
             </a:r>
           </a:p>
           <a:p>
-            <a:pPr marL="342900" indent="-342900">
+            <a:pPr marL="342900" indent="-342900" algn="just">
               <a:buFont typeface="Wingdings" panose="05000000000000000000" pitchFamily="2" charset="2"/>
               <a:buChar char="Ø"/>
             </a:pPr>
@@ -7336,7 +7340,7 @@
           </a:bodyPr>
           <a:lstStyle/>
           <a:p>
-            <a:pPr marL="342900" indent="-342900">
+            <a:pPr marL="342900" indent="-342900" algn="just">
               <a:buFont typeface="Wingdings" panose="05000000000000000000" pitchFamily="2" charset="2"/>
               <a:buChar char="Ø"/>
             </a:pPr>
@@ -7349,7 +7353,7 @@
             </a:r>
           </a:p>
           <a:p>
-            <a:pPr marL="342900" indent="-342900">
+            <a:pPr marL="342900" indent="-342900" algn="just">
               <a:buFont typeface="Wingdings" panose="05000000000000000000" pitchFamily="2" charset="2"/>
               <a:buChar char="ü"/>
             </a:pPr>
@@ -7362,7 +7366,7 @@
             </a:r>
           </a:p>
           <a:p>
-            <a:pPr marL="342900" indent="-342900">
+            <a:pPr marL="342900" indent="-342900" algn="just">
               <a:buFont typeface="Wingdings" panose="05000000000000000000" pitchFamily="2" charset="2"/>
               <a:buChar char="ü"/>
             </a:pPr>
@@ -7375,7 +7379,7 @@
             </a:r>
           </a:p>
           <a:p>
-            <a:pPr marL="342900" indent="-342900">
+            <a:pPr marL="342900" indent="-342900" algn="just">
               <a:buFont typeface="Wingdings" panose="05000000000000000000" pitchFamily="2" charset="2"/>
               <a:buChar char="ü"/>
             </a:pPr>
@@ -7388,7 +7392,7 @@
             </a:r>
           </a:p>
           <a:p>
-            <a:pPr marL="342900" indent="-342900">
+            <a:pPr marL="342900" indent="-342900" algn="just">
               <a:buFont typeface="Wingdings" panose="05000000000000000000" pitchFamily="2" charset="2"/>
               <a:buChar char="ü"/>
             </a:pPr>
@@ -7401,7 +7405,7 @@
             </a:r>
           </a:p>
           <a:p>
-            <a:pPr marL="342900" indent="-342900">
+            <a:pPr marL="342900" indent="-342900" algn="just">
               <a:buFont typeface="Wingdings" panose="05000000000000000000" pitchFamily="2" charset="2"/>
               <a:buChar char="ü"/>
             </a:pPr>
@@ -7414,7 +7418,7 @@
             </a:r>
           </a:p>
           <a:p>
-            <a:pPr marL="342900" indent="-342900">
+            <a:pPr marL="342900" indent="-342900" algn="just">
               <a:buFont typeface="Wingdings" panose="05000000000000000000" pitchFamily="2" charset="2"/>
               <a:buChar char="ü"/>
             </a:pPr>
@@ -7427,7 +7431,7 @@
             </a:r>
           </a:p>
           <a:p>
-            <a:pPr marL="342900" indent="-342900">
+            <a:pPr marL="342900" indent="-342900" algn="just">
               <a:buFont typeface="Wingdings" panose="05000000000000000000" pitchFamily="2" charset="2"/>
               <a:buChar char="ü"/>
             </a:pPr>

</xml_diff>

<commit_message>
Edited Report and PPT
</commit_message>
<xml_diff>
--- a/docs/Clg 1st review.pptx
+++ b/docs/Clg 1st review.pptx
@@ -5,7 +5,7 @@
     <p:sldMasterId id="2147483648" r:id="rId1"/>
   </p:sldMasterIdLst>
   <p:notesMasterIdLst>
-    <p:notesMasterId r:id="rId17"/>
+    <p:notesMasterId r:id="rId18"/>
   </p:notesMasterIdLst>
   <p:sldIdLst>
     <p:sldId id="263" r:id="rId2"/>
@@ -22,7 +22,8 @@
     <p:sldId id="275" r:id="rId13"/>
     <p:sldId id="273" r:id="rId14"/>
     <p:sldId id="274" r:id="rId15"/>
-    <p:sldId id="264" r:id="rId16"/>
+    <p:sldId id="277" r:id="rId16"/>
+    <p:sldId id="264" r:id="rId17"/>
   </p:sldIdLst>
   <p:sldSz cx="12192000" cy="6858000"/>
   <p:notesSz cx="6858000" cy="9144000"/>
@@ -211,7 +212,7 @@
           <a:p>
             <a:fld id="{C1BED7E8-5420-4F73-BA32-34A7030FE7D8}" type="datetimeFigureOut">
               <a:rPr lang="en-US" smtClean="0"/>
-              <a:t>2/19/2026</a:t>
+              <a:t>2/20/2026</a:t>
             </a:fld>
             <a:endParaRPr lang="en-US"/>
           </a:p>
@@ -886,6 +887,114 @@
 </p:notes>
 </file>
 
+<file path=ppt/notesSlides/notesSlide13.xml><?xml version="1.0" encoding="utf-8"?>
+<p:notes xmlns:a="http://schemas.openxmlformats.org/drawingml/2006/main" xmlns:r="http://schemas.openxmlformats.org/officeDocument/2006/relationships" xmlns:p="http://schemas.openxmlformats.org/presentationml/2006/main">
+  <p:cSld>
+    <p:spTree>
+      <p:nvGrpSpPr>
+        <p:cNvPr id="1" name="">
+          <a:extLst>
+            <a:ext uri="{FF2B5EF4-FFF2-40B4-BE49-F238E27FC236}">
+              <a16:creationId xmlns:a16="http://schemas.microsoft.com/office/drawing/2014/main" id="{05F8B92A-459E-CE51-0D67-D2726F6496F0}"/>
+            </a:ext>
+          </a:extLst>
+        </p:cNvPr>
+        <p:cNvGrpSpPr/>
+        <p:nvPr/>
+      </p:nvGrpSpPr>
+      <p:grpSpPr>
+        <a:xfrm>
+          <a:off x="0" y="0"/>
+          <a:ext cx="0" cy="0"/>
+          <a:chOff x="0" y="0"/>
+          <a:chExt cx="0" cy="0"/>
+        </a:xfrm>
+      </p:grpSpPr>
+      <p:sp>
+        <p:nvSpPr>
+          <p:cNvPr id="2" name="Slide Image Placeholder 1">
+            <a:extLst>
+              <a:ext uri="{FF2B5EF4-FFF2-40B4-BE49-F238E27FC236}">
+                <a16:creationId xmlns:a16="http://schemas.microsoft.com/office/drawing/2014/main" id="{59B24BF3-03DD-23E9-D677-E0B7DAB08234}"/>
+              </a:ext>
+            </a:extLst>
+          </p:cNvPr>
+          <p:cNvSpPr>
+            <a:spLocks noGrp="1" noRot="1" noChangeAspect="1"/>
+          </p:cNvSpPr>
+          <p:nvPr>
+            <p:ph type="sldImg"/>
+          </p:nvPr>
+        </p:nvSpPr>
+        <p:spPr/>
+      </p:sp>
+      <p:sp>
+        <p:nvSpPr>
+          <p:cNvPr id="3" name="Notes Placeholder 2">
+            <a:extLst>
+              <a:ext uri="{FF2B5EF4-FFF2-40B4-BE49-F238E27FC236}">
+                <a16:creationId xmlns:a16="http://schemas.microsoft.com/office/drawing/2014/main" id="{C3D874BA-689D-1ABD-21CD-4369FE25269D}"/>
+              </a:ext>
+            </a:extLst>
+          </p:cNvPr>
+          <p:cNvSpPr>
+            <a:spLocks noGrp="1"/>
+          </p:cNvSpPr>
+          <p:nvPr>
+            <p:ph type="body" idx="1"/>
+          </p:nvPr>
+        </p:nvSpPr>
+        <p:spPr/>
+        <p:txBody>
+          <a:bodyPr/>
+          <a:lstStyle/>
+          <a:p>
+            <a:endParaRPr lang="en-US" dirty="0"/>
+          </a:p>
+        </p:txBody>
+      </p:sp>
+      <p:sp>
+        <p:nvSpPr>
+          <p:cNvPr id="4" name="Slide Number Placeholder 3">
+            <a:extLst>
+              <a:ext uri="{FF2B5EF4-FFF2-40B4-BE49-F238E27FC236}">
+                <a16:creationId xmlns:a16="http://schemas.microsoft.com/office/drawing/2014/main" id="{7CD90BA1-CD2C-96FF-1BD3-D192CED24260}"/>
+              </a:ext>
+            </a:extLst>
+          </p:cNvPr>
+          <p:cNvSpPr>
+            <a:spLocks noGrp="1"/>
+          </p:cNvSpPr>
+          <p:nvPr>
+            <p:ph type="sldNum" sz="quarter" idx="5"/>
+          </p:nvPr>
+        </p:nvSpPr>
+        <p:spPr/>
+        <p:txBody>
+          <a:bodyPr/>
+          <a:lstStyle/>
+          <a:p>
+            <a:fld id="{C119E7F2-498D-45ED-A645-8BBCF90873D0}" type="slidenum">
+              <a:rPr lang="en-US" smtClean="0"/>
+              <a:t>15</a:t>
+            </a:fld>
+            <a:endParaRPr lang="en-US"/>
+          </a:p>
+        </p:txBody>
+      </p:sp>
+    </p:spTree>
+    <p:extLst>
+      <p:ext uri="{BB962C8B-B14F-4D97-AF65-F5344CB8AC3E}">
+        <p14:creationId xmlns:p14="http://schemas.microsoft.com/office/powerpoint/2010/main" val="922607664"/>
+      </p:ext>
+    </p:extLst>
+  </p:cSld>
+  <p:clrMapOvr>
+    <a:masterClrMapping/>
+  </p:clrMapOvr>
+</p:notes>
+</file>
+
 <file path=ppt/notesSlides/notesSlide2.xml><?xml version="1.0" encoding="utf-8"?>
 <p:notes xmlns:a="http://schemas.openxmlformats.org/drawingml/2006/main" xmlns:r="http://schemas.openxmlformats.org/officeDocument/2006/relationships" xmlns:p="http://schemas.openxmlformats.org/presentationml/2006/main">
   <p:cSld>
@@ -1873,7 +1982,7 @@
           <a:p>
             <a:fld id="{C198EE3F-C531-4F47-81BE-EB7857D8F039}" type="datetimeFigureOut">
               <a:rPr lang="en-US" smtClean="0"/>
-              <a:t>2/19/2026</a:t>
+              <a:t>2/20/2026</a:t>
             </a:fld>
             <a:endParaRPr lang="en-US"/>
           </a:p>
@@ -2071,7 +2180,7 @@
           <a:p>
             <a:fld id="{C198EE3F-C531-4F47-81BE-EB7857D8F039}" type="datetimeFigureOut">
               <a:rPr lang="en-US" smtClean="0"/>
-              <a:t>2/19/2026</a:t>
+              <a:t>2/20/2026</a:t>
             </a:fld>
             <a:endParaRPr lang="en-US"/>
           </a:p>
@@ -2279,7 +2388,7 @@
           <a:p>
             <a:fld id="{C198EE3F-C531-4F47-81BE-EB7857D8F039}" type="datetimeFigureOut">
               <a:rPr lang="en-US" smtClean="0"/>
-              <a:t>2/19/2026</a:t>
+              <a:t>2/20/2026</a:t>
             </a:fld>
             <a:endParaRPr lang="en-US"/>
           </a:p>
@@ -2477,7 +2586,7 @@
           <a:p>
             <a:fld id="{C198EE3F-C531-4F47-81BE-EB7857D8F039}" type="datetimeFigureOut">
               <a:rPr lang="en-US" smtClean="0"/>
-              <a:t>2/19/2026</a:t>
+              <a:t>2/20/2026</a:t>
             </a:fld>
             <a:endParaRPr lang="en-US"/>
           </a:p>
@@ -2752,7 +2861,7 @@
           <a:p>
             <a:fld id="{C198EE3F-C531-4F47-81BE-EB7857D8F039}" type="datetimeFigureOut">
               <a:rPr lang="en-US" smtClean="0"/>
-              <a:t>2/19/2026</a:t>
+              <a:t>2/20/2026</a:t>
             </a:fld>
             <a:endParaRPr lang="en-US"/>
           </a:p>
@@ -3017,7 +3126,7 @@
           <a:p>
             <a:fld id="{C198EE3F-C531-4F47-81BE-EB7857D8F039}" type="datetimeFigureOut">
               <a:rPr lang="en-US" smtClean="0"/>
-              <a:t>2/19/2026</a:t>
+              <a:t>2/20/2026</a:t>
             </a:fld>
             <a:endParaRPr lang="en-US"/>
           </a:p>
@@ -3429,7 +3538,7 @@
           <a:p>
             <a:fld id="{C198EE3F-C531-4F47-81BE-EB7857D8F039}" type="datetimeFigureOut">
               <a:rPr lang="en-US" smtClean="0"/>
-              <a:t>2/19/2026</a:t>
+              <a:t>2/20/2026</a:t>
             </a:fld>
             <a:endParaRPr lang="en-US"/>
           </a:p>
@@ -3570,7 +3679,7 @@
           <a:p>
             <a:fld id="{C198EE3F-C531-4F47-81BE-EB7857D8F039}" type="datetimeFigureOut">
               <a:rPr lang="en-US" smtClean="0"/>
-              <a:t>2/19/2026</a:t>
+              <a:t>2/20/2026</a:t>
             </a:fld>
             <a:endParaRPr lang="en-US"/>
           </a:p>
@@ -3683,7 +3792,7 @@
           <a:p>
             <a:fld id="{C198EE3F-C531-4F47-81BE-EB7857D8F039}" type="datetimeFigureOut">
               <a:rPr lang="en-US" smtClean="0"/>
-              <a:t>2/19/2026</a:t>
+              <a:t>2/20/2026</a:t>
             </a:fld>
             <a:endParaRPr lang="en-US"/>
           </a:p>
@@ -3994,7 +4103,7 @@
           <a:p>
             <a:fld id="{C198EE3F-C531-4F47-81BE-EB7857D8F039}" type="datetimeFigureOut">
               <a:rPr lang="en-US" smtClean="0"/>
-              <a:t>2/19/2026</a:t>
+              <a:t>2/20/2026</a:t>
             </a:fld>
             <a:endParaRPr lang="en-US"/>
           </a:p>
@@ -4282,7 +4391,7 @@
           <a:p>
             <a:fld id="{C198EE3F-C531-4F47-81BE-EB7857D8F039}" type="datetimeFigureOut">
               <a:rPr lang="en-US" smtClean="0"/>
-              <a:t>2/19/2026</a:t>
+              <a:t>2/20/2026</a:t>
             </a:fld>
             <a:endParaRPr lang="en-US"/>
           </a:p>
@@ -4523,7 +4632,7 @@
           <a:p>
             <a:fld id="{C198EE3F-C531-4F47-81BE-EB7857D8F039}" type="datetimeFigureOut">
               <a:rPr lang="en-US" smtClean="0"/>
-              <a:t>2/19/2026</a:t>
+              <a:t>2/20/2026</a:t>
             </a:fld>
             <a:endParaRPr lang="en-US"/>
           </a:p>
@@ -5255,7 +5364,7 @@
         </p:nvSpPr>
         <p:spPr>
           <a:xfrm>
-            <a:off x="265470" y="2563818"/>
+            <a:off x="265470" y="2445831"/>
             <a:ext cx="11661058" cy="4708981"/>
           </a:xfrm>
           <a:prstGeom prst="rect">
@@ -5276,6 +5385,7 @@
             <a:r>
               <a:rPr lang="en-US" sz="2000" b="1" dirty="0">
                 <a:latin typeface="Times New Roman" panose="02020603050405020304" pitchFamily="18" charset="0"/>
+                <a:ea typeface="Tahoma" panose="020B0604030504040204" pitchFamily="34" charset="0"/>
                 <a:cs typeface="Times New Roman" panose="02020603050405020304" pitchFamily="18" charset="0"/>
               </a:rPr>
               <a:t>Frontend Development</a:t>
@@ -5289,6 +5399,7 @@
             <a:r>
               <a:rPr lang="en-US" sz="2000" dirty="0">
                 <a:latin typeface="Times New Roman" panose="02020603050405020304" pitchFamily="18" charset="0"/>
+                <a:ea typeface="Tahoma" panose="020B0604030504040204" pitchFamily="34" charset="0"/>
                 <a:cs typeface="Times New Roman" panose="02020603050405020304" pitchFamily="18" charset="0"/>
               </a:rPr>
               <a:t>HTML</a:t>
@@ -5302,6 +5413,7 @@
             <a:r>
               <a:rPr lang="en-US" sz="2000" dirty="0">
                 <a:latin typeface="Times New Roman" panose="02020603050405020304" pitchFamily="18" charset="0"/>
+                <a:ea typeface="Tahoma" panose="020B0604030504040204" pitchFamily="34" charset="0"/>
                 <a:cs typeface="Times New Roman" panose="02020603050405020304" pitchFamily="18" charset="0"/>
               </a:rPr>
               <a:t>CSS</a:t>
@@ -5315,18 +5427,21 @@
             <a:r>
               <a:rPr lang="en-US" sz="2000" dirty="0" err="1">
                 <a:latin typeface="Times New Roman" panose="02020603050405020304" pitchFamily="18" charset="0"/>
+                <a:ea typeface="Tahoma" panose="020B0604030504040204" pitchFamily="34" charset="0"/>
                 <a:cs typeface="Times New Roman" panose="02020603050405020304" pitchFamily="18" charset="0"/>
               </a:rPr>
               <a:t>Javascript</a:t>
             </a:r>
             <a:endParaRPr lang="en-US" sz="2000" dirty="0">
               <a:latin typeface="Times New Roman" panose="02020603050405020304" pitchFamily="18" charset="0"/>
+              <a:ea typeface="Tahoma" panose="020B0604030504040204" pitchFamily="34" charset="0"/>
               <a:cs typeface="Times New Roman" panose="02020603050405020304" pitchFamily="18" charset="0"/>
             </a:endParaRPr>
           </a:p>
           <a:p>
             <a:endParaRPr lang="en-US" sz="2000" dirty="0">
               <a:latin typeface="Times New Roman" panose="02020603050405020304" pitchFamily="18" charset="0"/>
+              <a:ea typeface="Tahoma" panose="020B0604030504040204" pitchFamily="34" charset="0"/>
               <a:cs typeface="Times New Roman" panose="02020603050405020304" pitchFamily="18" charset="0"/>
             </a:endParaRPr>
           </a:p>
@@ -5338,6 +5453,7 @@
             <a:r>
               <a:rPr lang="en-US" sz="2000" b="1" dirty="0">
                 <a:latin typeface="Times New Roman" panose="02020603050405020304" pitchFamily="18" charset="0"/>
+                <a:ea typeface="Tahoma" panose="020B0604030504040204" pitchFamily="34" charset="0"/>
                 <a:cs typeface="Times New Roman" panose="02020603050405020304" pitchFamily="18" charset="0"/>
               </a:rPr>
               <a:t>Visualization</a:t>
@@ -5349,13 +5465,18 @@
               <a:buChar char="ü"/>
             </a:pPr>
             <a:r>
-              <a:rPr lang="en-US" sz="2000" dirty="0"/>
+              <a:rPr lang="en-US" sz="2000" dirty="0">
+                <a:latin typeface="Times New Roman" panose="02020603050405020304" pitchFamily="18" charset="0"/>
+                <a:ea typeface="Tahoma" panose="020B0604030504040204" pitchFamily="34" charset="0"/>
+                <a:cs typeface="Times New Roman" panose="02020603050405020304" pitchFamily="18" charset="0"/>
+              </a:rPr>
               <a:t>Tableau Public</a:t>
             </a:r>
           </a:p>
           <a:p>
             <a:endParaRPr lang="en-US" sz="2000" dirty="0">
               <a:latin typeface="Times New Roman" panose="02020603050405020304" pitchFamily="18" charset="0"/>
+              <a:ea typeface="Tahoma" panose="020B0604030504040204" pitchFamily="34" charset="0"/>
               <a:cs typeface="Times New Roman" panose="02020603050405020304" pitchFamily="18" charset="0"/>
             </a:endParaRPr>
           </a:p>
@@ -5367,6 +5488,7 @@
             <a:r>
               <a:rPr lang="en-US" sz="2000" b="1" dirty="0">
                 <a:latin typeface="Times New Roman" panose="02020603050405020304" pitchFamily="18" charset="0"/>
+                <a:ea typeface="Tahoma" panose="020B0604030504040204" pitchFamily="34" charset="0"/>
                 <a:cs typeface="Times New Roman" panose="02020603050405020304" pitchFamily="18" charset="0"/>
               </a:rPr>
               <a:t>Version Control</a:t>
@@ -5380,6 +5502,7 @@
             <a:r>
               <a:rPr lang="en-US" sz="2000" dirty="0">
                 <a:latin typeface="Times New Roman" panose="02020603050405020304" pitchFamily="18" charset="0"/>
+                <a:ea typeface="Tahoma" panose="020B0604030504040204" pitchFamily="34" charset="0"/>
                 <a:cs typeface="Times New Roman" panose="02020603050405020304" pitchFamily="18" charset="0"/>
               </a:rPr>
               <a:t>Git</a:t>
@@ -5388,6 +5511,7 @@
           <a:p>
             <a:endParaRPr lang="en-US" sz="2000" dirty="0">
               <a:latin typeface="Times New Roman" panose="02020603050405020304" pitchFamily="18" charset="0"/>
+              <a:ea typeface="Tahoma" panose="020B0604030504040204" pitchFamily="34" charset="0"/>
               <a:cs typeface="Times New Roman" panose="02020603050405020304" pitchFamily="18" charset="0"/>
             </a:endParaRPr>
           </a:p>
@@ -5399,11 +5523,11 @@
             <a:r>
               <a:rPr lang="en-US" sz="2000" b="1" dirty="0">
                 <a:latin typeface="Times New Roman" panose="02020603050405020304" pitchFamily="18" charset="0"/>
+                <a:ea typeface="Tahoma" panose="020B0604030504040204" pitchFamily="34" charset="0"/>
                 <a:cs typeface="Times New Roman" panose="02020603050405020304" pitchFamily="18" charset="0"/>
               </a:rPr>
               <a:t>Development Tools</a:t>
             </a:r>
-            <a:endParaRPr lang="en-US" sz="2000" b="1" dirty="0"/>
           </a:p>
           <a:p>
             <a:pPr marL="342900" indent="-342900">
@@ -5411,7 +5535,11 @@
               <a:buChar char="ü"/>
             </a:pPr>
             <a:r>
-              <a:rPr lang="en-US" sz="2000" dirty="0"/>
+              <a:rPr lang="en-US" sz="2000" dirty="0">
+                <a:latin typeface="Times New Roman" panose="02020603050405020304" pitchFamily="18" charset="0"/>
+                <a:ea typeface="Tahoma" panose="020B0604030504040204" pitchFamily="34" charset="0"/>
+                <a:cs typeface="Times New Roman" panose="02020603050405020304" pitchFamily="18" charset="0"/>
+              </a:rPr>
               <a:t>VS Code</a:t>
             </a:r>
           </a:p>
@@ -5421,11 +5549,19 @@
               <a:buChar char="ü"/>
             </a:pPr>
             <a:r>
-              <a:rPr lang="en-US" sz="2000" dirty="0" err="1"/>
+              <a:rPr lang="en-US" sz="2000" dirty="0" err="1">
+                <a:latin typeface="Times New Roman" panose="02020603050405020304" pitchFamily="18" charset="0"/>
+                <a:ea typeface="Tahoma" panose="020B0604030504040204" pitchFamily="34" charset="0"/>
+                <a:cs typeface="Times New Roman" panose="02020603050405020304" pitchFamily="18" charset="0"/>
+              </a:rPr>
               <a:t>Jupyter</a:t>
             </a:r>
             <a:r>
-              <a:rPr lang="en-US" sz="2000" dirty="0"/>
+              <a:rPr lang="en-US" sz="2000" dirty="0">
+                <a:latin typeface="Times New Roman" panose="02020603050405020304" pitchFamily="18" charset="0"/>
+                <a:ea typeface="Tahoma" panose="020B0604030504040204" pitchFamily="34" charset="0"/>
+                <a:cs typeface="Times New Roman" panose="02020603050405020304" pitchFamily="18" charset="0"/>
+              </a:rPr>
               <a:t> Notebook</a:t>
             </a:r>
           </a:p>
@@ -5434,7 +5570,11 @@
               <a:buFont typeface="Wingdings" panose="05000000000000000000" pitchFamily="2" charset="2"/>
               <a:buChar char="Ø"/>
             </a:pPr>
-            <a:endParaRPr lang="en-US" sz="2000" dirty="0"/>
+            <a:endParaRPr lang="en-US" sz="2000" dirty="0">
+              <a:latin typeface="Times New Roman" panose="02020603050405020304" pitchFamily="18" charset="0"/>
+              <a:ea typeface="Tahoma" panose="020B0604030504040204" pitchFamily="34" charset="0"/>
+              <a:cs typeface="Times New Roman" panose="02020603050405020304" pitchFamily="18" charset="0"/>
+            </a:endParaRPr>
           </a:p>
         </p:txBody>
       </p:sp>
@@ -5484,7 +5624,10 @@
               <a:buChar char="ü"/>
             </a:pPr>
             <a:r>
-              <a:rPr lang="en-US" sz="2000" dirty="0" err="1"/>
+              <a:rPr lang="en-US" sz="2000" dirty="0" err="1">
+                <a:latin typeface="Times New Roman" panose="02020603050405020304" pitchFamily="18" charset="0"/>
+                <a:cs typeface="Times New Roman" panose="02020603050405020304" pitchFamily="18" charset="0"/>
+              </a:rPr>
               <a:t>Supabase</a:t>
             </a:r>
             <a:endParaRPr lang="en-US" sz="2000" dirty="0">
@@ -5527,11 +5670,17 @@
               <a:buChar char="•"/>
             </a:pPr>
             <a:r>
-              <a:rPr lang="en-US" dirty="0" err="1"/>
+              <a:rPr lang="en-US" dirty="0" err="1">
+                <a:latin typeface="Times New Roman" panose="02020603050405020304" pitchFamily="18" charset="0"/>
+                <a:cs typeface="Times New Roman" panose="02020603050405020304" pitchFamily="18" charset="0"/>
+              </a:rPr>
               <a:t>Supabase</a:t>
             </a:r>
             <a:r>
-              <a:rPr lang="en-US" dirty="0"/>
+              <a:rPr lang="en-US" dirty="0">
+                <a:latin typeface="Times New Roman" panose="02020603050405020304" pitchFamily="18" charset="0"/>
+                <a:cs typeface="Times New Roman" panose="02020603050405020304" pitchFamily="18" charset="0"/>
+              </a:rPr>
               <a:t> PostgreSQL (Database)</a:t>
             </a:r>
           </a:p>
@@ -5541,11 +5690,17 @@
               <a:buChar char="•"/>
             </a:pPr>
             <a:r>
-              <a:rPr lang="en-US" dirty="0" err="1"/>
+              <a:rPr lang="en-US" dirty="0" err="1">
+                <a:latin typeface="Times New Roman" panose="02020603050405020304" pitchFamily="18" charset="0"/>
+                <a:cs typeface="Times New Roman" panose="02020603050405020304" pitchFamily="18" charset="0"/>
+              </a:rPr>
               <a:t>Supabase</a:t>
             </a:r>
             <a:r>
-              <a:rPr lang="en-US" dirty="0"/>
+              <a:rPr lang="en-US" dirty="0">
+                <a:latin typeface="Times New Roman" panose="02020603050405020304" pitchFamily="18" charset="0"/>
+                <a:cs typeface="Times New Roman" panose="02020603050405020304" pitchFamily="18" charset="0"/>
+              </a:rPr>
               <a:t> Storage (Cloud Storage)</a:t>
             </a:r>
           </a:p>
@@ -5555,11 +5710,17 @@
               <a:buChar char="•"/>
             </a:pPr>
             <a:r>
-              <a:rPr lang="en-US" dirty="0" err="1"/>
+              <a:rPr lang="en-US" dirty="0" err="1">
+                <a:latin typeface="Times New Roman" panose="02020603050405020304" pitchFamily="18" charset="0"/>
+                <a:cs typeface="Times New Roman" panose="02020603050405020304" pitchFamily="18" charset="0"/>
+              </a:rPr>
               <a:t>Supabase</a:t>
             </a:r>
             <a:r>
-              <a:rPr lang="en-US" dirty="0"/>
+              <a:rPr lang="en-US" dirty="0">
+                <a:latin typeface="Times New Roman" panose="02020603050405020304" pitchFamily="18" charset="0"/>
+                <a:cs typeface="Times New Roman" panose="02020603050405020304" pitchFamily="18" charset="0"/>
+              </a:rPr>
               <a:t> Auth (Authentication)</a:t>
             </a:r>
           </a:p>
@@ -6345,6 +6506,243 @@
 </file>
 
 <file path=ppt/slides/slide15.xml><?xml version="1.0" encoding="utf-8"?>
+<p:sld xmlns:a="http://schemas.openxmlformats.org/drawingml/2006/main" xmlns:r="http://schemas.openxmlformats.org/officeDocument/2006/relationships" xmlns:p="http://schemas.openxmlformats.org/presentationml/2006/main">
+  <p:cSld>
+    <p:spTree>
+      <p:nvGrpSpPr>
+        <p:cNvPr id="1" name="">
+          <a:extLst>
+            <a:ext uri="{FF2B5EF4-FFF2-40B4-BE49-F238E27FC236}">
+              <a16:creationId xmlns:a16="http://schemas.microsoft.com/office/drawing/2014/main" id="{C59E5E8E-A72F-34B6-59E1-F63AEE28DBEC}"/>
+            </a:ext>
+          </a:extLst>
+        </p:cNvPr>
+        <p:cNvGrpSpPr/>
+        <p:nvPr/>
+      </p:nvGrpSpPr>
+      <p:grpSpPr>
+        <a:xfrm>
+          <a:off x="0" y="0"/>
+          <a:ext cx="0" cy="0"/>
+          <a:chOff x="0" y="0"/>
+          <a:chExt cx="0" cy="0"/>
+        </a:xfrm>
+      </p:grpSpPr>
+      <p:sp>
+        <p:nvSpPr>
+          <p:cNvPr id="2" name="TextBox 1">
+            <a:extLst>
+              <a:ext uri="{FF2B5EF4-FFF2-40B4-BE49-F238E27FC236}">
+                <a16:creationId xmlns:a16="http://schemas.microsoft.com/office/drawing/2014/main" id="{685607D7-69BF-BC18-CB1B-DCFAD0B81110}"/>
+              </a:ext>
+            </a:extLst>
+          </p:cNvPr>
+          <p:cNvSpPr txBox="1"/>
+          <p:nvPr/>
+        </p:nvSpPr>
+        <p:spPr>
+          <a:xfrm>
+            <a:off x="265471" y="196645"/>
+            <a:ext cx="11661058" cy="523220"/>
+          </a:xfrm>
+          <a:prstGeom prst="rect">
+            <a:avLst/>
+          </a:prstGeom>
+          <a:noFill/>
+        </p:spPr>
+        <p:txBody>
+          <a:bodyPr wrap="square" rtlCol="0">
+            <a:spAutoFit/>
+          </a:bodyPr>
+          <a:lstStyle/>
+          <a:p>
+            <a:r>
+              <a:rPr lang="en-US" sz="2800" b="1" dirty="0"/>
+              <a:t>References </a:t>
+            </a:r>
+          </a:p>
+        </p:txBody>
+      </p:sp>
+      <p:sp>
+        <p:nvSpPr>
+          <p:cNvPr id="3" name="TextBox 2">
+            <a:extLst>
+              <a:ext uri="{FF2B5EF4-FFF2-40B4-BE49-F238E27FC236}">
+                <a16:creationId xmlns:a16="http://schemas.microsoft.com/office/drawing/2014/main" id="{82B85E94-AD04-7A66-ED75-5CAFAB042E8E}"/>
+              </a:ext>
+            </a:extLst>
+          </p:cNvPr>
+          <p:cNvSpPr txBox="1"/>
+          <p:nvPr/>
+        </p:nvSpPr>
+        <p:spPr>
+          <a:xfrm>
+            <a:off x="265471" y="792624"/>
+            <a:ext cx="11661058" cy="2554545"/>
+          </a:xfrm>
+          <a:prstGeom prst="rect">
+            <a:avLst/>
+          </a:prstGeom>
+          <a:noFill/>
+        </p:spPr>
+        <p:txBody>
+          <a:bodyPr wrap="square" rtlCol="0">
+            <a:spAutoFit/>
+          </a:bodyPr>
+          <a:lstStyle/>
+          <a:p>
+            <a:pPr marL="285750" lvl="0" indent="-285750" algn="just">
+              <a:buFont typeface="Wingdings" panose="05000000000000000000" pitchFamily="2" charset="2"/>
+              <a:buChar char="Ø"/>
+            </a:pPr>
+            <a:r>
+              <a:rPr lang="en-US" sz="2000" dirty="0">
+                <a:latin typeface="Times New Roman" panose="02020603050405020304" pitchFamily="18" charset="0"/>
+                <a:cs typeface="Times New Roman" panose="02020603050405020304" pitchFamily="18" charset="0"/>
+              </a:rPr>
+              <a:t>Dataset Reference: </a:t>
+            </a:r>
+            <a:r>
+              <a:rPr lang="en-US" sz="2000" u="sng" dirty="0">
+                <a:latin typeface="Times New Roman" panose="02020603050405020304" pitchFamily="18" charset="0"/>
+                <a:cs typeface="Times New Roman" panose="02020603050405020304" pitchFamily="18" charset="0"/>
+                <a:hlinkClick r:id="rId3"/>
+              </a:rPr>
+              <a:t>https://www.kaggle.com/datasets/stephanmatzka/predictive-maintenance-dataset-ai4i-2020</a:t>
+            </a:r>
+            <a:endParaRPr lang="en-US" sz="2000" dirty="0">
+              <a:latin typeface="Times New Roman" panose="02020603050405020304" pitchFamily="18" charset="0"/>
+              <a:cs typeface="Times New Roman" panose="02020603050405020304" pitchFamily="18" charset="0"/>
+            </a:endParaRPr>
+          </a:p>
+          <a:p>
+            <a:pPr marL="285750" indent="-285750" algn="just">
+              <a:buFont typeface="Wingdings" panose="05000000000000000000" pitchFamily="2" charset="2"/>
+              <a:buChar char="Ø"/>
+            </a:pPr>
+            <a:endParaRPr lang="en-US" sz="2000" dirty="0">
+              <a:latin typeface="Times New Roman" panose="02020603050405020304" pitchFamily="18" charset="0"/>
+              <a:cs typeface="Times New Roman" panose="02020603050405020304" pitchFamily="18" charset="0"/>
+            </a:endParaRPr>
+          </a:p>
+          <a:p>
+            <a:pPr marL="285750" lvl="0" indent="-285750" algn="just">
+              <a:buFont typeface="Wingdings" panose="05000000000000000000" pitchFamily="2" charset="2"/>
+              <a:buChar char="Ø"/>
+            </a:pPr>
+            <a:r>
+              <a:rPr lang="en-US" sz="2000" dirty="0">
+                <a:latin typeface="Times New Roman" panose="02020603050405020304" pitchFamily="18" charset="0"/>
+                <a:cs typeface="Times New Roman" panose="02020603050405020304" pitchFamily="18" charset="0"/>
+              </a:rPr>
+              <a:t>LSTM: </a:t>
+            </a:r>
+            <a:r>
+              <a:rPr lang="en-US" sz="2000" u="sng" dirty="0">
+                <a:latin typeface="Times New Roman" panose="02020603050405020304" pitchFamily="18" charset="0"/>
+                <a:cs typeface="Times New Roman" panose="02020603050405020304" pitchFamily="18" charset="0"/>
+                <a:hlinkClick r:id="rId4"/>
+              </a:rPr>
+              <a:t>https://www.geeksforgeeks.org/deep-learning/deep-learning-introduction-to-long-short-term-memory/</a:t>
+            </a:r>
+            <a:endParaRPr lang="en-US" sz="2000" dirty="0">
+              <a:latin typeface="Times New Roman" panose="02020603050405020304" pitchFamily="18" charset="0"/>
+              <a:cs typeface="Times New Roman" panose="02020603050405020304" pitchFamily="18" charset="0"/>
+            </a:endParaRPr>
+          </a:p>
+          <a:p>
+            <a:pPr marL="285750" indent="-285750" algn="just">
+              <a:buFont typeface="Wingdings" panose="05000000000000000000" pitchFamily="2" charset="2"/>
+              <a:buChar char="Ø"/>
+            </a:pPr>
+            <a:endParaRPr lang="en-US" sz="2000" dirty="0">
+              <a:latin typeface="Times New Roman" panose="02020603050405020304" pitchFamily="18" charset="0"/>
+              <a:cs typeface="Times New Roman" panose="02020603050405020304" pitchFamily="18" charset="0"/>
+            </a:endParaRPr>
+          </a:p>
+          <a:p>
+            <a:pPr marL="285750" lvl="0" indent="-285750" algn="just">
+              <a:buFont typeface="Wingdings" panose="05000000000000000000" pitchFamily="2" charset="2"/>
+              <a:buChar char="Ø"/>
+            </a:pPr>
+            <a:r>
+              <a:rPr lang="en-US" sz="2000" dirty="0" err="1">
+                <a:latin typeface="Times New Roman" panose="02020603050405020304" pitchFamily="18" charset="0"/>
+                <a:cs typeface="Times New Roman" panose="02020603050405020304" pitchFamily="18" charset="0"/>
+              </a:rPr>
+              <a:t>Keras</a:t>
+            </a:r>
+            <a:r>
+              <a:rPr lang="en-US" sz="2000" dirty="0">
+                <a:latin typeface="Times New Roman" panose="02020603050405020304" pitchFamily="18" charset="0"/>
+                <a:cs typeface="Times New Roman" panose="02020603050405020304" pitchFamily="18" charset="0"/>
+              </a:rPr>
+              <a:t>: </a:t>
+            </a:r>
+            <a:r>
+              <a:rPr lang="en-US" sz="2000" u="sng" dirty="0">
+                <a:latin typeface="Times New Roman" panose="02020603050405020304" pitchFamily="18" charset="0"/>
+                <a:cs typeface="Times New Roman" panose="02020603050405020304" pitchFamily="18" charset="0"/>
+                <a:hlinkClick r:id="rId5"/>
+              </a:rPr>
+              <a:t>https://keras.io</a:t>
+            </a:r>
+            <a:endParaRPr lang="en-US" sz="2000" dirty="0">
+              <a:latin typeface="Times New Roman" panose="02020603050405020304" pitchFamily="18" charset="0"/>
+              <a:cs typeface="Times New Roman" panose="02020603050405020304" pitchFamily="18" charset="0"/>
+            </a:endParaRPr>
+          </a:p>
+          <a:p>
+            <a:pPr marL="285750" indent="-285750" algn="just">
+              <a:buFont typeface="Wingdings" panose="05000000000000000000" pitchFamily="2" charset="2"/>
+              <a:buChar char="Ø"/>
+            </a:pPr>
+            <a:endParaRPr lang="en-US" sz="2000" dirty="0">
+              <a:latin typeface="Times New Roman" panose="02020603050405020304" pitchFamily="18" charset="0"/>
+              <a:cs typeface="Times New Roman" panose="02020603050405020304" pitchFamily="18" charset="0"/>
+            </a:endParaRPr>
+          </a:p>
+          <a:p>
+            <a:pPr marL="285750" lvl="0" indent="-285750" algn="just">
+              <a:buFont typeface="Wingdings" panose="05000000000000000000" pitchFamily="2" charset="2"/>
+              <a:buChar char="Ø"/>
+            </a:pPr>
+            <a:r>
+              <a:rPr lang="en-US" sz="2000" dirty="0">
+                <a:latin typeface="Times New Roman" panose="02020603050405020304" pitchFamily="18" charset="0"/>
+                <a:cs typeface="Times New Roman" panose="02020603050405020304" pitchFamily="18" charset="0"/>
+              </a:rPr>
+              <a:t>Flask: </a:t>
+            </a:r>
+            <a:r>
+              <a:rPr lang="en-US" sz="2000" u="sng" dirty="0">
+                <a:latin typeface="Times New Roman" panose="02020603050405020304" pitchFamily="18" charset="0"/>
+                <a:cs typeface="Times New Roman" panose="02020603050405020304" pitchFamily="18" charset="0"/>
+                <a:hlinkClick r:id="rId6"/>
+              </a:rPr>
+              <a:t>https://flask.palletsprojects.com/en/stable/</a:t>
+            </a:r>
+            <a:endParaRPr lang="en-US" sz="2000" dirty="0">
+              <a:latin typeface="Times New Roman" panose="02020603050405020304" pitchFamily="18" charset="0"/>
+              <a:cs typeface="Times New Roman" panose="02020603050405020304" pitchFamily="18" charset="0"/>
+            </a:endParaRPr>
+          </a:p>
+        </p:txBody>
+      </p:sp>
+    </p:spTree>
+    <p:extLst>
+      <p:ext uri="{BB962C8B-B14F-4D97-AF65-F5344CB8AC3E}">
+        <p14:creationId xmlns:p14="http://schemas.microsoft.com/office/powerpoint/2010/main" val="3285586311"/>
+      </p:ext>
+    </p:extLst>
+  </p:cSld>
+  <p:clrMapOvr>
+    <a:masterClrMapping/>
+  </p:clrMapOvr>
+</p:sld>
+</file>
+
+<file path=ppt/slides/slide16.xml><?xml version="1.0" encoding="utf-8"?>
 <p:sld xmlns:a="http://schemas.openxmlformats.org/drawingml/2006/main" xmlns:r="http://schemas.openxmlformats.org/officeDocument/2006/relationships" xmlns:p="http://schemas.openxmlformats.org/presentationml/2006/main">
   <p:cSld>
     <p:spTree>

</xml_diff>